<commit_message>
Update poster with manual edits
</commit_message>
<xml_diff>
--- a/Agent_Eval_Poster.pptx
+++ b/Agent_Eval_Poster.pptx
@@ -5,9 +5,9 @@
     <p:sldMasterId id="2147483648" r:id="rId1"/>
   </p:sldMasterIdLst>
   <p:sldIdLst>
-    <p:sldId id="256" r:id="rId7"/>
+    <p:sldId id="256" r:id="rId2"/>
   </p:sldIdLst>
-  <p:sldSz cx="15124176" cy="10689336" type="screen4x3"/>
+  <p:sldSz cx="15124113" cy="10688638"/>
   <p:notesSz cx="6858000" cy="9144000"/>
   <p:defaultTextStyle>
     <a:defPPr>
@@ -104,7 +104,132 @@
       </a:defRPr>
     </a:lvl9pPr>
   </p:defaultTextStyle>
+  <p:extLst>
+    <p:ext uri="{EFAFB233-063F-42B5-8137-9DF3F51BA10A}">
+      <p15:sldGuideLst xmlns:p15="http://schemas.microsoft.com/office/powerpoint/2012/main">
+        <p15:guide id="1" orient="horz" pos="2160">
+          <p15:clr>
+            <a:srgbClr val="A4A3A4"/>
+          </p15:clr>
+        </p15:guide>
+        <p15:guide id="2" pos="2880">
+          <p15:clr>
+            <a:srgbClr val="A4A3A4"/>
+          </p15:clr>
+        </p15:guide>
+      </p15:sldGuideLst>
+    </p:ext>
+  </p:extLst>
 </p:presentation>
+</file>
+
+<file path=ppt/changesInfos/changesInfo1.xml><?xml version="1.0" encoding="utf-8"?>
+<pc:chgInfo xmlns:a="http://schemas.openxmlformats.org/drawingml/2006/main" xmlns:r="http://schemas.openxmlformats.org/officeDocument/2006/relationships" xmlns:ac="http://schemas.microsoft.com/office/drawing/2013/main/command" xmlns:pc="http://schemas.microsoft.com/office/powerpoint/2013/main/command">
+  <pc:docChgLst>
+    <pc:chgData name="Arnav Jain" userId="f2adf29d-2619-42a8-86da-ba577201478b" providerId="ADAL" clId="{51CE8724-7848-51D2-B085-D619A97C2260}"/>
+    <pc:docChg chg="modSld">
+      <pc:chgData name="Arnav Jain" userId="f2adf29d-2619-42a8-86da-ba577201478b" providerId="ADAL" clId="{51CE8724-7848-51D2-B085-D619A97C2260}" dt="2026-07-02T09:08:05.365" v="43" actId="1038"/>
+      <pc:docMkLst>
+        <pc:docMk/>
+      </pc:docMkLst>
+      <pc:sldChg chg="modSp mod">
+        <pc:chgData name="Arnav Jain" userId="f2adf29d-2619-42a8-86da-ba577201478b" providerId="ADAL" clId="{51CE8724-7848-51D2-B085-D619A97C2260}" dt="2026-07-02T09:08:05.365" v="43" actId="1038"/>
+        <pc:sldMkLst>
+          <pc:docMk/>
+          <pc:sldMk cId="0" sldId="256"/>
+        </pc:sldMkLst>
+        <pc:spChg chg="mod">
+          <ac:chgData name="Arnav Jain" userId="f2adf29d-2619-42a8-86da-ba577201478b" providerId="ADAL" clId="{51CE8724-7848-51D2-B085-D619A97C2260}" dt="2026-07-02T09:04:01.083" v="9" actId="20577"/>
+          <ac:spMkLst>
+            <pc:docMk/>
+            <pc:sldMk cId="0" sldId="256"/>
+            <ac:spMk id="15" creationId="{00000000-0000-0000-0000-000000000000}"/>
+          </ac:spMkLst>
+        </pc:spChg>
+        <pc:spChg chg="mod">
+          <ac:chgData name="Arnav Jain" userId="f2adf29d-2619-42a8-86da-ba577201478b" providerId="ADAL" clId="{51CE8724-7848-51D2-B085-D619A97C2260}" dt="2026-07-02T09:03:00.945" v="1" actId="20577"/>
+          <ac:spMkLst>
+            <pc:docMk/>
+            <pc:sldMk cId="0" sldId="256"/>
+            <ac:spMk id="35" creationId="{00000000-0000-0000-0000-000000000000}"/>
+          </ac:spMkLst>
+        </pc:spChg>
+        <pc:spChg chg="mod">
+          <ac:chgData name="Arnav Jain" userId="f2adf29d-2619-42a8-86da-ba577201478b" providerId="ADAL" clId="{51CE8724-7848-51D2-B085-D619A97C2260}" dt="2026-07-02T09:03:33.903" v="6" actId="255"/>
+          <ac:spMkLst>
+            <pc:docMk/>
+            <pc:sldMk cId="0" sldId="256"/>
+            <ac:spMk id="42" creationId="{00000000-0000-0000-0000-000000000000}"/>
+          </ac:spMkLst>
+        </pc:spChg>
+        <pc:spChg chg="mod">
+          <ac:chgData name="Arnav Jain" userId="f2adf29d-2619-42a8-86da-ba577201478b" providerId="ADAL" clId="{51CE8724-7848-51D2-B085-D619A97C2260}" dt="2026-07-02T09:03:07.670" v="3" actId="20577"/>
+          <ac:spMkLst>
+            <pc:docMk/>
+            <pc:sldMk cId="0" sldId="256"/>
+            <ac:spMk id="45" creationId="{00000000-0000-0000-0000-000000000000}"/>
+          </ac:spMkLst>
+        </pc:spChg>
+        <pc:spChg chg="mod">
+          <ac:chgData name="Arnav Jain" userId="f2adf29d-2619-42a8-86da-ba577201478b" providerId="ADAL" clId="{51CE8724-7848-51D2-B085-D619A97C2260}" dt="2026-07-02T09:07:39.748" v="12" actId="1036"/>
+          <ac:spMkLst>
+            <pc:docMk/>
+            <pc:sldMk cId="0" sldId="256"/>
+            <ac:spMk id="47" creationId="{00000000-0000-0000-0000-000000000000}"/>
+          </ac:spMkLst>
+        </pc:spChg>
+        <pc:spChg chg="mod">
+          <ac:chgData name="Arnav Jain" userId="f2adf29d-2619-42a8-86da-ba577201478b" providerId="ADAL" clId="{51CE8724-7848-51D2-B085-D619A97C2260}" dt="2026-07-02T09:07:55.874" v="28" actId="1035"/>
+          <ac:spMkLst>
+            <pc:docMk/>
+            <pc:sldMk cId="0" sldId="256"/>
+            <ac:spMk id="49" creationId="{00000000-0000-0000-0000-000000000000}"/>
+          </ac:spMkLst>
+        </pc:spChg>
+        <pc:spChg chg="mod">
+          <ac:chgData name="Arnav Jain" userId="f2adf29d-2619-42a8-86da-ba577201478b" providerId="ADAL" clId="{51CE8724-7848-51D2-B085-D619A97C2260}" dt="2026-07-02T09:08:05.365" v="43" actId="1038"/>
+          <ac:spMkLst>
+            <pc:docMk/>
+            <pc:sldMk cId="0" sldId="256"/>
+            <ac:spMk id="50" creationId="{00000000-0000-0000-0000-000000000000}"/>
+          </ac:spMkLst>
+        </pc:spChg>
+        <pc:spChg chg="mod">
+          <ac:chgData name="Arnav Jain" userId="f2adf29d-2619-42a8-86da-ba577201478b" providerId="ADAL" clId="{51CE8724-7848-51D2-B085-D619A97C2260}" dt="2026-07-02T09:08:02.768" v="36" actId="1038"/>
+          <ac:spMkLst>
+            <pc:docMk/>
+            <pc:sldMk cId="0" sldId="256"/>
+            <ac:spMk id="51" creationId="{00000000-0000-0000-0000-000000000000}"/>
+          </ac:spMkLst>
+        </pc:spChg>
+        <pc:picChg chg="mod">
+          <ac:chgData name="Arnav Jain" userId="f2adf29d-2619-42a8-86da-ba577201478b" providerId="ADAL" clId="{51CE8724-7848-51D2-B085-D619A97C2260}" dt="2026-07-02T09:03:54.221" v="7" actId="14100"/>
+          <ac:picMkLst>
+            <pc:docMk/>
+            <pc:sldMk cId="0" sldId="256"/>
+            <ac:picMk id="24" creationId="{00000000-0000-0000-0000-000000000000}"/>
+          </ac:picMkLst>
+        </pc:picChg>
+        <pc:picChg chg="mod">
+          <ac:chgData name="Arnav Jain" userId="f2adf29d-2619-42a8-86da-ba577201478b" providerId="ADAL" clId="{51CE8724-7848-51D2-B085-D619A97C2260}" dt="2026-07-02T09:07:42.179" v="16" actId="1036"/>
+          <ac:picMkLst>
+            <pc:docMk/>
+            <pc:sldMk cId="0" sldId="256"/>
+            <ac:picMk id="46" creationId="{00000000-0000-0000-0000-000000000000}"/>
+          </ac:picMkLst>
+        </pc:picChg>
+        <pc:picChg chg="mod">
+          <ac:chgData name="Arnav Jain" userId="f2adf29d-2619-42a8-86da-ba577201478b" providerId="ADAL" clId="{51CE8724-7848-51D2-B085-D619A97C2260}" dt="2026-07-02T09:07:52.021" v="26" actId="1035"/>
+          <ac:picMkLst>
+            <pc:docMk/>
+            <pc:sldMk cId="0" sldId="256"/>
+            <ac:picMk id="48" creationId="{00000000-0000-0000-0000-000000000000}"/>
+          </ac:picMkLst>
+        </pc:picChg>
+      </pc:sldChg>
+    </pc:docChg>
+  </pc:docChgLst>
+</pc:chgInfo>
 </file>
 
 <file path=ppt/slideLayouts/slideLayout1.xml><?xml version="1.0" encoding="utf-8"?>
@@ -145,10 +270,9 @@
           <a:lstStyle/>
           <a:p>
             <a:r>
-              <a:rPr lang="en-US" smtClean="0"/>
+              <a:rPr lang="en-US"/>
               <a:t>Click to edit Master title style</a:t>
             </a:r>
-            <a:endParaRPr lang="en-US"/>
           </a:p>
         </p:txBody>
       </p:sp>
@@ -264,10 +388,9 @@
           </a:lstStyle>
           <a:p>
             <a:r>
-              <a:rPr lang="en-US" smtClean="0"/>
+              <a:rPr lang="en-US"/>
               <a:t>Click to edit Master subtitle style</a:t>
             </a:r>
-            <a:endParaRPr lang="en-US"/>
           </a:p>
         </p:txBody>
       </p:sp>
@@ -288,7 +411,7 @@
           <a:p>
             <a:fld id="{5BCAD085-E8A6-8845-BD4E-CB4CCA059FC4}" type="datetimeFigureOut">
               <a:rPr lang="en-US" smtClean="0"/>
-              <a:t>1/27/13</a:t>
+              <a:t>7/2/26</a:t>
             </a:fld>
             <a:endParaRPr lang="en-US"/>
           </a:p>
@@ -382,10 +505,9 @@
           <a:lstStyle/>
           <a:p>
             <a:r>
-              <a:rPr lang="en-US" smtClean="0"/>
+              <a:rPr lang="en-US"/>
               <a:t>Click to edit Master title style</a:t>
             </a:r>
-            <a:endParaRPr lang="en-US"/>
           </a:p>
         </p:txBody>
       </p:sp>
@@ -406,38 +528,37 @@
           <a:p>
             <a:pPr lvl="0"/>
             <a:r>
-              <a:rPr lang="en-US" smtClean="0"/>
+              <a:rPr lang="en-US"/>
               <a:t>Click to edit Master text styles</a:t>
             </a:r>
           </a:p>
           <a:p>
             <a:pPr lvl="1"/>
             <a:r>
-              <a:rPr lang="en-US" smtClean="0"/>
+              <a:rPr lang="en-US"/>
               <a:t>Second level</a:t>
             </a:r>
           </a:p>
           <a:p>
             <a:pPr lvl="2"/>
             <a:r>
-              <a:rPr lang="en-US" smtClean="0"/>
+              <a:rPr lang="en-US"/>
               <a:t>Third level</a:t>
             </a:r>
           </a:p>
           <a:p>
             <a:pPr lvl="3"/>
             <a:r>
-              <a:rPr lang="en-US" smtClean="0"/>
+              <a:rPr lang="en-US"/>
               <a:t>Fourth level</a:t>
             </a:r>
           </a:p>
           <a:p>
             <a:pPr lvl="4"/>
             <a:r>
-              <a:rPr lang="en-US" smtClean="0"/>
+              <a:rPr lang="en-US"/>
               <a:t>Fifth level</a:t>
             </a:r>
-            <a:endParaRPr lang="en-US"/>
           </a:p>
         </p:txBody>
       </p:sp>
@@ -458,7 +579,7 @@
           <a:p>
             <a:fld id="{5BCAD085-E8A6-8845-BD4E-CB4CCA059FC4}" type="datetimeFigureOut">
               <a:rPr lang="en-US" smtClean="0"/>
-              <a:t>1/27/13</a:t>
+              <a:t>7/2/26</a:t>
             </a:fld>
             <a:endParaRPr lang="en-US"/>
           </a:p>
@@ -557,10 +678,9 @@
           <a:lstStyle/>
           <a:p>
             <a:r>
-              <a:rPr lang="en-US" smtClean="0"/>
+              <a:rPr lang="en-US"/>
               <a:t>Click to edit Master title style</a:t>
             </a:r>
-            <a:endParaRPr lang="en-US"/>
           </a:p>
         </p:txBody>
       </p:sp>
@@ -586,38 +706,37 @@
           <a:p>
             <a:pPr lvl="0"/>
             <a:r>
-              <a:rPr lang="en-US" smtClean="0"/>
+              <a:rPr lang="en-US"/>
               <a:t>Click to edit Master text styles</a:t>
             </a:r>
           </a:p>
           <a:p>
             <a:pPr lvl="1"/>
             <a:r>
-              <a:rPr lang="en-US" smtClean="0"/>
+              <a:rPr lang="en-US"/>
               <a:t>Second level</a:t>
             </a:r>
           </a:p>
           <a:p>
             <a:pPr lvl="2"/>
             <a:r>
-              <a:rPr lang="en-US" smtClean="0"/>
+              <a:rPr lang="en-US"/>
               <a:t>Third level</a:t>
             </a:r>
           </a:p>
           <a:p>
             <a:pPr lvl="3"/>
             <a:r>
-              <a:rPr lang="en-US" smtClean="0"/>
+              <a:rPr lang="en-US"/>
               <a:t>Fourth level</a:t>
             </a:r>
           </a:p>
           <a:p>
             <a:pPr lvl="4"/>
             <a:r>
-              <a:rPr lang="en-US" smtClean="0"/>
+              <a:rPr lang="en-US"/>
               <a:t>Fifth level</a:t>
             </a:r>
-            <a:endParaRPr lang="en-US"/>
           </a:p>
         </p:txBody>
       </p:sp>
@@ -638,7 +757,7 @@
           <a:p>
             <a:fld id="{5BCAD085-E8A6-8845-BD4E-CB4CCA059FC4}" type="datetimeFigureOut">
               <a:rPr lang="en-US" smtClean="0"/>
-              <a:t>1/27/13</a:t>
+              <a:t>7/2/26</a:t>
             </a:fld>
             <a:endParaRPr lang="en-US"/>
           </a:p>
@@ -732,10 +851,9 @@
           <a:lstStyle/>
           <a:p>
             <a:r>
-              <a:rPr lang="en-US" smtClean="0"/>
+              <a:rPr lang="en-US"/>
               <a:t>Click to edit Master title style</a:t>
             </a:r>
-            <a:endParaRPr lang="en-US"/>
           </a:p>
         </p:txBody>
       </p:sp>
@@ -756,38 +874,37 @@
           <a:p>
             <a:pPr lvl="0"/>
             <a:r>
-              <a:rPr lang="en-US" smtClean="0"/>
+              <a:rPr lang="en-US"/>
               <a:t>Click to edit Master text styles</a:t>
             </a:r>
           </a:p>
           <a:p>
             <a:pPr lvl="1"/>
             <a:r>
-              <a:rPr lang="en-US" smtClean="0"/>
+              <a:rPr lang="en-US"/>
               <a:t>Second level</a:t>
             </a:r>
           </a:p>
           <a:p>
             <a:pPr lvl="2"/>
             <a:r>
-              <a:rPr lang="en-US" smtClean="0"/>
+              <a:rPr lang="en-US"/>
               <a:t>Third level</a:t>
             </a:r>
           </a:p>
           <a:p>
             <a:pPr lvl="3"/>
             <a:r>
-              <a:rPr lang="en-US" smtClean="0"/>
+              <a:rPr lang="en-US"/>
               <a:t>Fourth level</a:t>
             </a:r>
           </a:p>
           <a:p>
             <a:pPr lvl="4"/>
             <a:r>
-              <a:rPr lang="en-US" smtClean="0"/>
+              <a:rPr lang="en-US"/>
               <a:t>Fifth level</a:t>
             </a:r>
-            <a:endParaRPr lang="en-US"/>
           </a:p>
         </p:txBody>
       </p:sp>
@@ -808,7 +925,7 @@
           <a:p>
             <a:fld id="{5BCAD085-E8A6-8845-BD4E-CB4CCA059FC4}" type="datetimeFigureOut">
               <a:rPr lang="en-US" smtClean="0"/>
-              <a:t>1/27/13</a:t>
+              <a:t>7/2/26</a:t>
             </a:fld>
             <a:endParaRPr lang="en-US"/>
           </a:p>
@@ -911,10 +1028,9 @@
           </a:lstStyle>
           <a:p>
             <a:r>
-              <a:rPr lang="en-US" smtClean="0"/>
+              <a:rPr lang="en-US"/>
               <a:t>Click to edit Master title style</a:t>
             </a:r>
-            <a:endParaRPr lang="en-US"/>
           </a:p>
         </p:txBody>
       </p:sp>
@@ -1031,7 +1147,7 @@
           <a:p>
             <a:pPr lvl="0"/>
             <a:r>
-              <a:rPr lang="en-US" smtClean="0"/>
+              <a:rPr lang="en-US"/>
               <a:t>Click to edit Master text styles</a:t>
             </a:r>
           </a:p>
@@ -1054,7 +1170,7 @@
           <a:p>
             <a:fld id="{5BCAD085-E8A6-8845-BD4E-CB4CCA059FC4}" type="datetimeFigureOut">
               <a:rPr lang="en-US" smtClean="0"/>
-              <a:t>1/27/13</a:t>
+              <a:t>7/2/26</a:t>
             </a:fld>
             <a:endParaRPr lang="en-US"/>
           </a:p>
@@ -1148,10 +1264,9 @@
           <a:lstStyle/>
           <a:p>
             <a:r>
-              <a:rPr lang="en-US" smtClean="0"/>
+              <a:rPr lang="en-US"/>
               <a:t>Click to edit Master title style</a:t>
             </a:r>
-            <a:endParaRPr lang="en-US"/>
           </a:p>
         </p:txBody>
       </p:sp>
@@ -1205,38 +1320,37 @@
           <a:p>
             <a:pPr lvl="0"/>
             <a:r>
-              <a:rPr lang="en-US" smtClean="0"/>
+              <a:rPr lang="en-US"/>
               <a:t>Click to edit Master text styles</a:t>
             </a:r>
           </a:p>
           <a:p>
             <a:pPr lvl="1"/>
             <a:r>
-              <a:rPr lang="en-US" smtClean="0"/>
+              <a:rPr lang="en-US"/>
               <a:t>Second level</a:t>
             </a:r>
           </a:p>
           <a:p>
             <a:pPr lvl="2"/>
             <a:r>
-              <a:rPr lang="en-US" smtClean="0"/>
+              <a:rPr lang="en-US"/>
               <a:t>Third level</a:t>
             </a:r>
           </a:p>
           <a:p>
             <a:pPr lvl="3"/>
             <a:r>
-              <a:rPr lang="en-US" smtClean="0"/>
+              <a:rPr lang="en-US"/>
               <a:t>Fourth level</a:t>
             </a:r>
           </a:p>
           <a:p>
             <a:pPr lvl="4"/>
             <a:r>
-              <a:rPr lang="en-US" smtClean="0"/>
+              <a:rPr lang="en-US"/>
               <a:t>Fifth level</a:t>
             </a:r>
-            <a:endParaRPr lang="en-US"/>
           </a:p>
         </p:txBody>
       </p:sp>
@@ -1290,38 +1404,37 @@
           <a:p>
             <a:pPr lvl="0"/>
             <a:r>
-              <a:rPr lang="en-US" smtClean="0"/>
+              <a:rPr lang="en-US"/>
               <a:t>Click to edit Master text styles</a:t>
             </a:r>
           </a:p>
           <a:p>
             <a:pPr lvl="1"/>
             <a:r>
-              <a:rPr lang="en-US" smtClean="0"/>
+              <a:rPr lang="en-US"/>
               <a:t>Second level</a:t>
             </a:r>
           </a:p>
           <a:p>
             <a:pPr lvl="2"/>
             <a:r>
-              <a:rPr lang="en-US" smtClean="0"/>
+              <a:rPr lang="en-US"/>
               <a:t>Third level</a:t>
             </a:r>
           </a:p>
           <a:p>
             <a:pPr lvl="3"/>
             <a:r>
-              <a:rPr lang="en-US" smtClean="0"/>
+              <a:rPr lang="en-US"/>
               <a:t>Fourth level</a:t>
             </a:r>
           </a:p>
           <a:p>
             <a:pPr lvl="4"/>
             <a:r>
-              <a:rPr lang="en-US" smtClean="0"/>
+              <a:rPr lang="en-US"/>
               <a:t>Fifth level</a:t>
             </a:r>
-            <a:endParaRPr lang="en-US"/>
           </a:p>
         </p:txBody>
       </p:sp>
@@ -1342,7 +1455,7 @@
           <a:p>
             <a:fld id="{5BCAD085-E8A6-8845-BD4E-CB4CCA059FC4}" type="datetimeFigureOut">
               <a:rPr lang="en-US" smtClean="0"/>
-              <a:t>1/27/13</a:t>
+              <a:t>7/2/26</a:t>
             </a:fld>
             <a:endParaRPr lang="en-US"/>
           </a:p>
@@ -1440,10 +1553,9 @@
           </a:lstStyle>
           <a:p>
             <a:r>
-              <a:rPr lang="en-US" smtClean="0"/>
+              <a:rPr lang="en-US"/>
               <a:t>Click to edit Master title style</a:t>
             </a:r>
-            <a:endParaRPr lang="en-US"/>
           </a:p>
         </p:txBody>
       </p:sp>
@@ -1506,7 +1618,7 @@
           <a:p>
             <a:pPr lvl="0"/>
             <a:r>
-              <a:rPr lang="en-US" smtClean="0"/>
+              <a:rPr lang="en-US"/>
               <a:t>Click to edit Master text styles</a:t>
             </a:r>
           </a:p>
@@ -1562,38 +1674,37 @@
           <a:p>
             <a:pPr lvl="0"/>
             <a:r>
-              <a:rPr lang="en-US" smtClean="0"/>
+              <a:rPr lang="en-US"/>
               <a:t>Click to edit Master text styles</a:t>
             </a:r>
           </a:p>
           <a:p>
             <a:pPr lvl="1"/>
             <a:r>
-              <a:rPr lang="en-US" smtClean="0"/>
+              <a:rPr lang="en-US"/>
               <a:t>Second level</a:t>
             </a:r>
           </a:p>
           <a:p>
             <a:pPr lvl="2"/>
             <a:r>
-              <a:rPr lang="en-US" smtClean="0"/>
+              <a:rPr lang="en-US"/>
               <a:t>Third level</a:t>
             </a:r>
           </a:p>
           <a:p>
             <a:pPr lvl="3"/>
             <a:r>
-              <a:rPr lang="en-US" smtClean="0"/>
+              <a:rPr lang="en-US"/>
               <a:t>Fourth level</a:t>
             </a:r>
           </a:p>
           <a:p>
             <a:pPr lvl="4"/>
             <a:r>
-              <a:rPr lang="en-US" smtClean="0"/>
+              <a:rPr lang="en-US"/>
               <a:t>Fifth level</a:t>
             </a:r>
-            <a:endParaRPr lang="en-US"/>
           </a:p>
         </p:txBody>
       </p:sp>
@@ -1656,7 +1767,7 @@
           <a:p>
             <a:pPr lvl="0"/>
             <a:r>
-              <a:rPr lang="en-US" smtClean="0"/>
+              <a:rPr lang="en-US"/>
               <a:t>Click to edit Master text styles</a:t>
             </a:r>
           </a:p>
@@ -1712,38 +1823,37 @@
           <a:p>
             <a:pPr lvl="0"/>
             <a:r>
-              <a:rPr lang="en-US" smtClean="0"/>
+              <a:rPr lang="en-US"/>
               <a:t>Click to edit Master text styles</a:t>
             </a:r>
           </a:p>
           <a:p>
             <a:pPr lvl="1"/>
             <a:r>
-              <a:rPr lang="en-US" smtClean="0"/>
+              <a:rPr lang="en-US"/>
               <a:t>Second level</a:t>
             </a:r>
           </a:p>
           <a:p>
             <a:pPr lvl="2"/>
             <a:r>
-              <a:rPr lang="en-US" smtClean="0"/>
+              <a:rPr lang="en-US"/>
               <a:t>Third level</a:t>
             </a:r>
           </a:p>
           <a:p>
             <a:pPr lvl="3"/>
             <a:r>
-              <a:rPr lang="en-US" smtClean="0"/>
+              <a:rPr lang="en-US"/>
               <a:t>Fourth level</a:t>
             </a:r>
           </a:p>
           <a:p>
             <a:pPr lvl="4"/>
             <a:r>
-              <a:rPr lang="en-US" smtClean="0"/>
+              <a:rPr lang="en-US"/>
               <a:t>Fifth level</a:t>
             </a:r>
-            <a:endParaRPr lang="en-US"/>
           </a:p>
         </p:txBody>
       </p:sp>
@@ -1764,7 +1874,7 @@
           <a:p>
             <a:fld id="{5BCAD085-E8A6-8845-BD4E-CB4CCA059FC4}" type="datetimeFigureOut">
               <a:rPr lang="en-US" smtClean="0"/>
-              <a:t>1/27/13</a:t>
+              <a:t>7/2/26</a:t>
             </a:fld>
             <a:endParaRPr lang="en-US"/>
           </a:p>
@@ -1858,10 +1968,9 @@
           <a:lstStyle/>
           <a:p>
             <a:r>
-              <a:rPr lang="en-US" smtClean="0"/>
+              <a:rPr lang="en-US"/>
               <a:t>Click to edit Master title style</a:t>
             </a:r>
-            <a:endParaRPr lang="en-US"/>
           </a:p>
         </p:txBody>
       </p:sp>
@@ -1882,7 +1991,7 @@
           <a:p>
             <a:fld id="{5BCAD085-E8A6-8845-BD4E-CB4CCA059FC4}" type="datetimeFigureOut">
               <a:rPr lang="en-US" smtClean="0"/>
-              <a:t>1/27/13</a:t>
+              <a:t>7/2/26</a:t>
             </a:fld>
             <a:endParaRPr lang="en-US"/>
           </a:p>
@@ -1977,7 +2086,7 @@
           <a:p>
             <a:fld id="{5BCAD085-E8A6-8845-BD4E-CB4CCA059FC4}" type="datetimeFigureOut">
               <a:rPr lang="en-US" smtClean="0"/>
-              <a:t>1/27/13</a:t>
+              <a:t>7/2/26</a:t>
             </a:fld>
             <a:endParaRPr lang="en-US"/>
           </a:p>
@@ -2080,10 +2189,9 @@
           </a:lstStyle>
           <a:p>
             <a:r>
-              <a:rPr lang="en-US" smtClean="0"/>
+              <a:rPr lang="en-US"/>
               <a:t>Click to edit Master title style</a:t>
             </a:r>
-            <a:endParaRPr lang="en-US"/>
           </a:p>
         </p:txBody>
       </p:sp>
@@ -2137,38 +2245,37 @@
           <a:p>
             <a:pPr lvl="0"/>
             <a:r>
-              <a:rPr lang="en-US" smtClean="0"/>
+              <a:rPr lang="en-US"/>
               <a:t>Click to edit Master text styles</a:t>
             </a:r>
           </a:p>
           <a:p>
             <a:pPr lvl="1"/>
             <a:r>
-              <a:rPr lang="en-US" smtClean="0"/>
+              <a:rPr lang="en-US"/>
               <a:t>Second level</a:t>
             </a:r>
           </a:p>
           <a:p>
             <a:pPr lvl="2"/>
             <a:r>
-              <a:rPr lang="en-US" smtClean="0"/>
+              <a:rPr lang="en-US"/>
               <a:t>Third level</a:t>
             </a:r>
           </a:p>
           <a:p>
             <a:pPr lvl="3"/>
             <a:r>
-              <a:rPr lang="en-US" smtClean="0"/>
+              <a:rPr lang="en-US"/>
               <a:t>Fourth level</a:t>
             </a:r>
           </a:p>
           <a:p>
             <a:pPr lvl="4"/>
             <a:r>
-              <a:rPr lang="en-US" smtClean="0"/>
+              <a:rPr lang="en-US"/>
               <a:t>Fifth level</a:t>
             </a:r>
-            <a:endParaRPr lang="en-US"/>
           </a:p>
         </p:txBody>
       </p:sp>
@@ -2231,7 +2338,7 @@
           <a:p>
             <a:pPr lvl="0"/>
             <a:r>
-              <a:rPr lang="en-US" smtClean="0"/>
+              <a:rPr lang="en-US"/>
               <a:t>Click to edit Master text styles</a:t>
             </a:r>
           </a:p>
@@ -2254,7 +2361,7 @@
           <a:p>
             <a:fld id="{5BCAD085-E8A6-8845-BD4E-CB4CCA059FC4}" type="datetimeFigureOut">
               <a:rPr lang="en-US" smtClean="0"/>
-              <a:t>1/27/13</a:t>
+              <a:t>7/2/26</a:t>
             </a:fld>
             <a:endParaRPr lang="en-US"/>
           </a:p>
@@ -2357,10 +2464,9 @@
           </a:lstStyle>
           <a:p>
             <a:r>
-              <a:rPr lang="en-US" smtClean="0"/>
+              <a:rPr lang="en-US"/>
               <a:t>Click to edit Master title style</a:t>
             </a:r>
-            <a:endParaRPr lang="en-US"/>
           </a:p>
         </p:txBody>
       </p:sp>
@@ -2484,7 +2590,7 @@
           <a:p>
             <a:pPr lvl="0"/>
             <a:r>
-              <a:rPr lang="en-US" smtClean="0"/>
+              <a:rPr lang="en-US"/>
               <a:t>Click to edit Master text styles</a:t>
             </a:r>
           </a:p>
@@ -2507,7 +2613,7 @@
           <a:p>
             <a:fld id="{5BCAD085-E8A6-8845-BD4E-CB4CCA059FC4}" type="datetimeFigureOut">
               <a:rPr lang="en-US" smtClean="0"/>
-              <a:t>1/27/13</a:t>
+              <a:t>7/2/26</a:t>
             </a:fld>
             <a:endParaRPr lang="en-US"/>
           </a:p>
@@ -2616,10 +2722,9 @@
           <a:lstStyle/>
           <a:p>
             <a:r>
-              <a:rPr lang="en-US" smtClean="0"/>
+              <a:rPr lang="en-US"/>
               <a:t>Click to edit Master title style</a:t>
             </a:r>
-            <a:endParaRPr lang="en-US"/>
           </a:p>
         </p:txBody>
       </p:sp>
@@ -2650,38 +2755,37 @@
           <a:p>
             <a:pPr lvl="0"/>
             <a:r>
-              <a:rPr lang="en-US" smtClean="0"/>
+              <a:rPr lang="en-US"/>
               <a:t>Click to edit Master text styles</a:t>
             </a:r>
           </a:p>
           <a:p>
             <a:pPr lvl="1"/>
             <a:r>
-              <a:rPr lang="en-US" smtClean="0"/>
+              <a:rPr lang="en-US"/>
               <a:t>Second level</a:t>
             </a:r>
           </a:p>
           <a:p>
             <a:pPr lvl="2"/>
             <a:r>
-              <a:rPr lang="en-US" smtClean="0"/>
+              <a:rPr lang="en-US"/>
               <a:t>Third level</a:t>
             </a:r>
           </a:p>
           <a:p>
             <a:pPr lvl="3"/>
             <a:r>
-              <a:rPr lang="en-US" smtClean="0"/>
+              <a:rPr lang="en-US"/>
               <a:t>Fourth level</a:t>
             </a:r>
           </a:p>
           <a:p>
             <a:pPr lvl="4"/>
             <a:r>
-              <a:rPr lang="en-US" smtClean="0"/>
+              <a:rPr lang="en-US"/>
               <a:t>Fifth level</a:t>
             </a:r>
-            <a:endParaRPr lang="en-US"/>
           </a:p>
         </p:txBody>
       </p:sp>
@@ -2720,7 +2824,7 @@
           <a:p>
             <a:fld id="{5BCAD085-E8A6-8845-BD4E-CB4CCA059FC4}" type="datetimeFigureOut">
               <a:rPr lang="en-US" smtClean="0"/>
-              <a:t>1/27/13</a:t>
+              <a:t>7/2/26</a:t>
             </a:fld>
             <a:endParaRPr lang="en-US"/>
           </a:p>
@@ -3079,7 +3183,7 @@
 </file>
 
 <file path=ppt/slides/slide1.xml><?xml version="1.0" encoding="utf-8"?>
-<p:sld xmlns:a="http://schemas.openxmlformats.org/drawingml/2006/main" xmlns:p="http://schemas.openxmlformats.org/presentationml/2006/main" xmlns:r="http://schemas.openxmlformats.org/officeDocument/2006/relationships">
+<p:sld xmlns:a="http://schemas.openxmlformats.org/drawingml/2006/main" xmlns:r="http://schemas.openxmlformats.org/officeDocument/2006/relationships" xmlns:p="http://schemas.openxmlformats.org/presentationml/2006/main">
   <p:cSld>
     <p:spTree>
       <p:nvGrpSpPr>
@@ -3087,7 +3191,14 @@
         <p:cNvGrpSpPr/>
         <p:nvPr/>
       </p:nvGrpSpPr>
-      <p:grpSpPr/>
+      <p:grpSpPr>
+        <a:xfrm>
+          <a:off x="0" y="0"/>
+          <a:ext cx="0" cy="0"/>
+          <a:chOff x="0" y="0"/>
+          <a:chExt cx="0" cy="0"/>
+        </a:xfrm>
+      </p:grpSpPr>
       <p:sp>
         <p:nvSpPr>
           <p:cNvPr id="2" name="Rectangle 1"/>
@@ -3128,6 +3239,7 @@
           <a:lstStyle/>
           <a:p>
             <a:pPr algn="ctr"/>
+            <a:endParaRPr/>
           </a:p>
         </p:txBody>
       </p:sp>
@@ -3171,6 +3283,7 @@
           <a:lstStyle/>
           <a:p>
             <a:pPr algn="ctr"/>
+            <a:endParaRPr/>
           </a:p>
         </p:txBody>
       </p:sp>
@@ -3239,7 +3352,7 @@
           <a:noFill/>
         </p:spPr>
         <p:txBody>
-          <a:bodyPr wrap="square" lIns="45720" rIns="45720" tIns="27432" bIns="27432">
+          <a:bodyPr wrap="square" lIns="45720" tIns="27432" rIns="45720" bIns="27432">
             <a:spAutoFit/>
           </a:bodyPr>
           <a:lstStyle/>
@@ -3275,7 +3388,7 @@
           <a:noFill/>
         </p:spPr>
         <p:txBody>
-          <a:bodyPr wrap="square" lIns="45720" rIns="45720" tIns="27432" bIns="27432">
+          <a:bodyPr wrap="square" lIns="45720" tIns="27432" rIns="45720" bIns="27432">
             <a:spAutoFit/>
           </a:bodyPr>
           <a:lstStyle/>
@@ -3311,7 +3424,7 @@
           <a:noFill/>
         </p:spPr>
         <p:txBody>
-          <a:bodyPr wrap="square" lIns="45720" rIns="45720" tIns="27432" bIns="27432">
+          <a:bodyPr wrap="square" lIns="45720" tIns="27432" rIns="45720" bIns="27432">
             <a:spAutoFit/>
           </a:bodyPr>
           <a:lstStyle/>
@@ -3347,7 +3460,7 @@
           <a:noFill/>
         </p:spPr>
         <p:txBody>
-          <a:bodyPr wrap="square" lIns="45720" rIns="45720" tIns="27432" bIns="27432">
+          <a:bodyPr wrap="square" lIns="45720" tIns="27432" rIns="45720" bIns="27432">
             <a:spAutoFit/>
           </a:bodyPr>
           <a:lstStyle/>
@@ -3406,6 +3519,7 @@
           <a:lstStyle/>
           <a:p>
             <a:pPr algn="ctr"/>
+            <a:endParaRPr/>
           </a:p>
         </p:txBody>
       </p:sp>
@@ -3451,6 +3565,7 @@
           <a:lstStyle/>
           <a:p>
             <a:pPr algn="ctr"/>
+            <a:endParaRPr/>
           </a:p>
         </p:txBody>
       </p:sp>
@@ -3494,6 +3609,7 @@
           <a:lstStyle/>
           <a:p>
             <a:pPr algn="ctr"/>
+            <a:endParaRPr/>
           </a:p>
         </p:txBody>
       </p:sp>
@@ -3514,7 +3630,7 @@
           <a:noFill/>
         </p:spPr>
         <p:txBody>
-          <a:bodyPr wrap="square" lIns="45720" rIns="45720" tIns="27432" bIns="27432">
+          <a:bodyPr wrap="square" lIns="45720" tIns="27432" rIns="45720" bIns="27432">
             <a:spAutoFit/>
           </a:bodyPr>
           <a:lstStyle/>
@@ -3550,7 +3666,7 @@
           <a:noFill/>
         </p:spPr>
         <p:txBody>
-          <a:bodyPr wrap="square" lIns="45720" rIns="45720" tIns="27432" bIns="27432">
+          <a:bodyPr wrap="square" lIns="45720" tIns="27432" rIns="45720" bIns="27432">
             <a:spAutoFit/>
           </a:bodyPr>
           <a:lstStyle/>
@@ -3586,7 +3702,7 @@
           <a:noFill/>
         </p:spPr>
         <p:txBody>
-          <a:bodyPr wrap="square" lIns="45720" rIns="45720" tIns="27432">
+          <a:bodyPr wrap="square" lIns="45720" tIns="27432" rIns="45720">
             <a:spAutoFit/>
           </a:bodyPr>
           <a:lstStyle/>
@@ -3667,7 +3783,14 @@
               </a:defRPr>
             </a:pPr>
             <a:r>
-              <a:t>•  Agentic AI is a rapidly emerging frontier — governance is critical for a regulated industry.</a:t>
+              <a:t>•  Agentic AI is a rapidly emerging frontier </a:t>
+            </a:r>
+            <a:r>
+              <a:rPr lang="en-US"/>
+              <a:t>-</a:t>
+            </a:r>
+            <a:r>
+              <a:t> governance is critical for a regulated industry.</a:t>
             </a:r>
           </a:p>
         </p:txBody>
@@ -3714,6 +3837,7 @@
           <a:lstStyle/>
           <a:p>
             <a:pPr algn="ctr"/>
+            <a:endParaRPr/>
           </a:p>
         </p:txBody>
       </p:sp>
@@ -3757,6 +3881,7 @@
           <a:lstStyle/>
           <a:p>
             <a:pPr algn="ctr"/>
+            <a:endParaRPr/>
           </a:p>
         </p:txBody>
       </p:sp>
@@ -3777,7 +3902,7 @@
           <a:noFill/>
         </p:spPr>
         <p:txBody>
-          <a:bodyPr wrap="square" lIns="45720" rIns="45720" tIns="27432" bIns="27432">
+          <a:bodyPr wrap="square" lIns="45720" tIns="27432" rIns="45720" bIns="27432">
             <a:spAutoFit/>
           </a:bodyPr>
           <a:lstStyle/>
@@ -3813,7 +3938,7 @@
           <a:noFill/>
         </p:spPr>
         <p:txBody>
-          <a:bodyPr wrap="square" lIns="45720" rIns="45720" tIns="27432" bIns="27432">
+          <a:bodyPr wrap="square" lIns="45720" tIns="27432" rIns="45720" bIns="27432">
             <a:spAutoFit/>
           </a:bodyPr>
           <a:lstStyle/>
@@ -3849,7 +3974,7 @@
           <a:noFill/>
         </p:spPr>
         <p:txBody>
-          <a:bodyPr wrap="square" lIns="45720" rIns="45720" tIns="27432">
+          <a:bodyPr wrap="square" lIns="45720" tIns="27432" rIns="45720">
             <a:spAutoFit/>
           </a:bodyPr>
           <a:lstStyle/>
@@ -3961,6 +4086,7 @@
           <a:lstStyle/>
           <a:p>
             <a:pPr algn="ctr"/>
+            <a:endParaRPr/>
           </a:p>
         </p:txBody>
       </p:sp>
@@ -4004,6 +4130,7 @@
           <a:lstStyle/>
           <a:p>
             <a:pPr algn="ctr"/>
+            <a:endParaRPr/>
           </a:p>
         </p:txBody>
       </p:sp>
@@ -4024,7 +4151,7 @@
           <a:noFill/>
         </p:spPr>
         <p:txBody>
-          <a:bodyPr wrap="square" lIns="45720" rIns="45720" tIns="27432" bIns="27432">
+          <a:bodyPr wrap="square" lIns="45720" tIns="27432" rIns="45720" bIns="27432">
             <a:spAutoFit/>
           </a:bodyPr>
           <a:lstStyle/>
@@ -4059,8 +4186,8 @@
         </p:blipFill>
         <p:spPr>
           <a:xfrm>
-            <a:off x="3904488" y="2331720"/>
-            <a:ext cx="8119871" cy="1530304"/>
+            <a:off x="3852140" y="2321854"/>
+            <a:ext cx="8172220" cy="1540170"/>
           </a:xfrm>
           <a:prstGeom prst="rect">
             <a:avLst/>
@@ -4084,7 +4211,7 @@
           <a:noFill/>
         </p:spPr>
         <p:txBody>
-          <a:bodyPr wrap="square" lIns="45720" rIns="45720" tIns="27432" bIns="27432">
+          <a:bodyPr wrap="square" lIns="45720" tIns="27432" rIns="45720" bIns="27432">
             <a:spAutoFit/>
           </a:bodyPr>
           <a:lstStyle/>
@@ -4143,6 +4270,7 @@
           <a:lstStyle/>
           <a:p>
             <a:pPr algn="ctr"/>
+            <a:endParaRPr/>
           </a:p>
         </p:txBody>
       </p:sp>
@@ -4163,7 +4291,7 @@
           <a:noFill/>
         </p:spPr>
         <p:txBody>
-          <a:bodyPr wrap="square" lIns="45720" rIns="45720" tIns="27432" bIns="27432">
+          <a:bodyPr wrap="square" lIns="45720" tIns="27432" rIns="45720" bIns="27432">
             <a:spAutoFit/>
           </a:bodyPr>
           <a:lstStyle/>
@@ -4218,7 +4346,7 @@
           </a:fontRef>
         </p:style>
         <p:txBody>
-          <a:bodyPr rtlCol="0" anchor="ctr" wrap="square" tIns="54864" bIns="54864"/>
+          <a:bodyPr wrap="square" tIns="54864" bIns="54864" rtlCol="0" anchor="ctr"/>
           <a:lstStyle/>
           <a:p>
             <a:pPr algn="ctr">
@@ -4299,6 +4427,7 @@
           <a:lstStyle/>
           <a:p>
             <a:pPr algn="ctr"/>
+            <a:endParaRPr/>
           </a:p>
         </p:txBody>
       </p:sp>
@@ -4338,7 +4467,7 @@
           </a:fontRef>
         </p:style>
         <p:txBody>
-          <a:bodyPr rtlCol="0" anchor="ctr" wrap="square" tIns="54864" bIns="54864"/>
+          <a:bodyPr wrap="square" tIns="54864" bIns="54864" rtlCol="0" anchor="ctr"/>
           <a:lstStyle/>
           <a:p>
             <a:pPr algn="ctr">
@@ -4419,6 +4548,7 @@
           <a:lstStyle/>
           <a:p>
             <a:pPr algn="ctr"/>
+            <a:endParaRPr/>
           </a:p>
         </p:txBody>
       </p:sp>
@@ -4458,7 +4588,7 @@
           </a:fontRef>
         </p:style>
         <p:txBody>
-          <a:bodyPr rtlCol="0" anchor="ctr" wrap="square" tIns="54864" bIns="54864"/>
+          <a:bodyPr wrap="square" tIns="54864" bIns="54864" rtlCol="0" anchor="ctr"/>
           <a:lstStyle/>
           <a:p>
             <a:pPr algn="ctr">
@@ -4541,6 +4671,7 @@
           <a:lstStyle/>
           <a:p>
             <a:pPr algn="ctr"/>
+            <a:endParaRPr/>
           </a:p>
         </p:txBody>
       </p:sp>
@@ -4584,6 +4715,7 @@
           <a:lstStyle/>
           <a:p>
             <a:pPr algn="ctr"/>
+            <a:endParaRPr/>
           </a:p>
         </p:txBody>
       </p:sp>
@@ -4596,7 +4728,7 @@
         <p:spPr>
           <a:xfrm>
             <a:off x="12527280" y="1737360"/>
-            <a:ext cx="2432304" cy="457200"/>
+            <a:ext cx="2432304" cy="393954"/>
           </a:xfrm>
           <a:prstGeom prst="rect">
             <a:avLst/>
@@ -4604,7 +4736,7 @@
           <a:noFill/>
         </p:spPr>
         <p:txBody>
-          <a:bodyPr wrap="square" lIns="45720" rIns="45720" tIns="27432" bIns="27432">
+          <a:bodyPr wrap="square" lIns="45720" tIns="27432" rIns="45720" bIns="27432">
             <a:spAutoFit/>
           </a:bodyPr>
           <a:lstStyle/>
@@ -4618,7 +4750,11 @@
               </a:defRPr>
             </a:pPr>
             <a:r>
-              <a:t>5.  Multi-Model</a:t>
+              <a:rPr lang="en-US"/>
+              <a:t>4</a:t>
+            </a:r>
+            <a:r>
+              <a:t>.  Multi-Model</a:t>
             </a:r>
           </a:p>
         </p:txBody>
@@ -4640,7 +4776,7 @@
           <a:noFill/>
         </p:spPr>
         <p:txBody>
-          <a:bodyPr wrap="square" lIns="45720" rIns="45720" tIns="27432" bIns="27432">
+          <a:bodyPr wrap="square" lIns="45720" tIns="27432" rIns="45720" bIns="27432">
             <a:spAutoFit/>
           </a:bodyPr>
           <a:lstStyle/>
@@ -4729,7 +4865,7 @@
           <a:noFill/>
         </p:spPr>
         <p:txBody>
-          <a:bodyPr wrap="square" lIns="45720" rIns="45720" tIns="27432" bIns="27432">
+          <a:bodyPr wrap="square" lIns="45720" tIns="27432" rIns="45720" bIns="27432">
             <a:spAutoFit/>
           </a:bodyPr>
           <a:lstStyle/>
@@ -4841,6 +4977,7 @@
           <a:lstStyle/>
           <a:p>
             <a:pPr algn="ctr"/>
+            <a:endParaRPr/>
           </a:p>
         </p:txBody>
       </p:sp>
@@ -4906,7 +5043,7 @@
         <p:spPr>
           <a:xfrm>
             <a:off x="12499848" y="5038344"/>
-            <a:ext cx="2432304" cy="539495"/>
+            <a:ext cx="2432304" cy="704808"/>
           </a:xfrm>
           <a:prstGeom prst="rect">
             <a:avLst/>
@@ -4914,7 +5051,7 @@
           <a:noFill/>
         </p:spPr>
         <p:txBody>
-          <a:bodyPr wrap="square" lIns="45720" rIns="45720" tIns="27432">
+          <a:bodyPr wrap="square" lIns="45720" tIns="27432" rIns="45720">
             <a:spAutoFit/>
           </a:bodyPr>
           <a:lstStyle/>
@@ -4931,6 +5068,7 @@
               </a:defRPr>
             </a:pPr>
             <a:r>
+              <a:rPr sz="1200"/>
               <a:t>•  Consensus verdict.</a:t>
             </a:r>
           </a:p>
@@ -4947,6 +5085,7 @@
               </a:defRPr>
             </a:pPr>
             <a:r>
+              <a:rPr sz="1200"/>
               <a:t>•  Reduces single-model bias.</a:t>
             </a:r>
           </a:p>
@@ -4963,6 +5102,7 @@
               </a:defRPr>
             </a:pPr>
             <a:r>
+              <a:rPr sz="1200"/>
               <a:t>•  Full audit trail.</a:t>
             </a:r>
           </a:p>
@@ -5010,6 +5150,7 @@
           <a:lstStyle/>
           <a:p>
             <a:pPr algn="ctr"/>
+            <a:endParaRPr/>
           </a:p>
         </p:txBody>
       </p:sp>
@@ -5053,6 +5194,7 @@
           <a:lstStyle/>
           <a:p>
             <a:pPr algn="ctr"/>
+            <a:endParaRPr/>
           </a:p>
         </p:txBody>
       </p:sp>
@@ -5065,7 +5207,7 @@
         <p:spPr>
           <a:xfrm>
             <a:off x="3931920" y="5916167"/>
-            <a:ext cx="11027663" cy="457200"/>
+            <a:ext cx="11027663" cy="393954"/>
           </a:xfrm>
           <a:prstGeom prst="rect">
             <a:avLst/>
@@ -5073,7 +5215,7 @@
           <a:noFill/>
         </p:spPr>
         <p:txBody>
-          <a:bodyPr wrap="square" lIns="45720" rIns="45720" tIns="27432" bIns="27432">
+          <a:bodyPr wrap="square" lIns="45720" tIns="27432" rIns="45720" bIns="27432">
             <a:spAutoFit/>
           </a:bodyPr>
           <a:lstStyle/>
@@ -5087,7 +5229,11 @@
               </a:defRPr>
             </a:pPr>
             <a:r>
-              <a:t>6.  Results &amp; Impact</a:t>
+              <a:rPr lang="en-US"/>
+              <a:t>5</a:t>
+            </a:r>
+            <a:r>
+              <a:t>.  Results &amp; Impact</a:t>
             </a:r>
           </a:p>
         </p:txBody>
@@ -5109,8 +5255,8 @@
         </p:blipFill>
         <p:spPr>
           <a:xfrm>
-            <a:off x="4263399" y="6537959"/>
-            <a:ext cx="3302501" cy="3447288"/>
+            <a:off x="4133089" y="6468435"/>
+            <a:ext cx="3432812" cy="3583312"/>
           </a:xfrm>
           <a:prstGeom prst="rect">
             <a:avLst/>
@@ -5125,7 +5271,7 @@
         </p:nvSpPr>
         <p:spPr>
           <a:xfrm>
-            <a:off x="4263399" y="10030968"/>
+            <a:off x="4263399" y="10064218"/>
             <a:ext cx="3302501" cy="228600"/>
           </a:xfrm>
           <a:prstGeom prst="rect">
@@ -5134,7 +5280,7 @@
           <a:noFill/>
         </p:spPr>
         <p:txBody>
-          <a:bodyPr wrap="square" lIns="45720" rIns="45720" tIns="27432" bIns="27432">
+          <a:bodyPr wrap="square" lIns="45720" tIns="27432" rIns="45720" bIns="27432">
             <a:spAutoFit/>
           </a:bodyPr>
           <a:lstStyle/>
@@ -5170,8 +5316,8 @@
         </p:blipFill>
         <p:spPr>
           <a:xfrm>
-            <a:off x="7767069" y="6537959"/>
-            <a:ext cx="3302501" cy="3447288"/>
+            <a:off x="7636759" y="6468436"/>
+            <a:ext cx="3432811" cy="3583311"/>
           </a:xfrm>
           <a:prstGeom prst="rect">
             <a:avLst/>
@@ -5186,7 +5332,7 @@
         </p:nvSpPr>
         <p:spPr>
           <a:xfrm>
-            <a:off x="7767069" y="10030968"/>
+            <a:off x="7767069" y="10047593"/>
             <a:ext cx="3302501" cy="228600"/>
           </a:xfrm>
           <a:prstGeom prst="rect">
@@ -5195,7 +5341,7 @@
           <a:noFill/>
         </p:spPr>
         <p:txBody>
-          <a:bodyPr wrap="square" lIns="45720" rIns="45720" tIns="27432" bIns="27432">
+          <a:bodyPr wrap="square" lIns="45720" tIns="27432" rIns="45720" bIns="27432">
             <a:spAutoFit/>
           </a:bodyPr>
           <a:lstStyle/>
@@ -5222,7 +5368,7 @@
         </p:nvSpPr>
         <p:spPr>
           <a:xfrm>
-            <a:off x="11270738" y="6537959"/>
+            <a:off x="11387113" y="6537959"/>
             <a:ext cx="3302501" cy="347472"/>
           </a:xfrm>
           <a:prstGeom prst="rect">
@@ -5231,7 +5377,7 @@
           <a:noFill/>
         </p:spPr>
         <p:txBody>
-          <a:bodyPr wrap="square" lIns="45720" rIns="45720" tIns="27432" bIns="27432">
+          <a:bodyPr wrap="square" lIns="45720" tIns="27432" rIns="45720" bIns="27432">
             <a:spAutoFit/>
           </a:bodyPr>
           <a:lstStyle/>
@@ -5258,8 +5404,8 @@
         </p:nvSpPr>
         <p:spPr>
           <a:xfrm>
-            <a:off x="11270738" y="6949439"/>
-            <a:ext cx="3302501" cy="3035808"/>
+            <a:off x="11403738" y="6949439"/>
+            <a:ext cx="3302501" cy="2828467"/>
           </a:xfrm>
           <a:prstGeom prst="rect">
             <a:avLst/>
@@ -5267,7 +5413,7 @@
           <a:noFill/>
         </p:spPr>
         <p:txBody>
-          <a:bodyPr wrap="square" lIns="45720" rIns="45720" tIns="27432">
+          <a:bodyPr wrap="square" lIns="45720" tIns="27432" rIns="45720">
             <a:spAutoFit/>
           </a:bodyPr>
           <a:lstStyle/>
@@ -5284,6 +5430,7 @@
               </a:defRPr>
             </a:pPr>
             <a:r>
+              <a:rPr sz="1400"/>
               <a:t>•  Reusable SDK with a single-function entry point.</a:t>
             </a:r>
           </a:p>
@@ -5300,6 +5447,7 @@
               </a:defRPr>
             </a:pPr>
             <a:r>
+              <a:rPr sz="1400"/>
               <a:t>•  Auto-generates evaluation criteria from any agent I/O.</a:t>
             </a:r>
           </a:p>
@@ -5316,6 +5464,7 @@
               </a:defRPr>
             </a:pPr>
             <a:r>
+              <a:rPr sz="1400"/>
               <a:t>•  Scores outputs across 5 governance pillars via 15 evaluators.</a:t>
             </a:r>
           </a:p>
@@ -5332,6 +5481,7 @@
               </a:defRPr>
             </a:pPr>
             <a:r>
+              <a:rPr sz="1400"/>
               <a:t>•  Supports single-model and multi-model consensus judgement.</a:t>
             </a:r>
           </a:p>
@@ -5348,6 +5498,7 @@
               </a:defRPr>
             </a:pPr>
             <a:r>
+              <a:rPr sz="1400"/>
               <a:t>•  Runs on the internal Eli Lilly LLM Gateway.</a:t>
             </a:r>
           </a:p>
@@ -5364,6 +5515,7 @@
               </a:defRPr>
             </a:pPr>
             <a:r>
+              <a:rPr sz="1400"/>
               <a:t>•  Emits a self-contained, interactive HTML report per run.</a:t>
             </a:r>
           </a:p>
@@ -5409,6 +5561,7 @@
           <a:lstStyle/>
           <a:p>
             <a:pPr algn="ctr"/>
+            <a:endParaRPr/>
           </a:p>
         </p:txBody>
       </p:sp>
@@ -5429,7 +5582,7 @@
           <a:noFill/>
         </p:spPr>
         <p:txBody>
-          <a:bodyPr wrap="square" lIns="45720" rIns="45720" tIns="27432" bIns="27432">
+          <a:bodyPr wrap="square" lIns="45720" tIns="27432" rIns="45720" bIns="27432">
             <a:spAutoFit/>
           </a:bodyPr>
           <a:lstStyle/>

</xml_diff>